<commit_message>
Benchmark Infosys's open-source guardrails; add AgentOS hook adapter
Run Foundry PromptGuard, the RAI moderation proxy's message selection and the
Topaz AgentOS pre-tool gate from Infosys's own source on the KAVACH suite
(same held-out split and metrics). Write up the measured gaps, correct the
blueprint and deck claim that Foundry has only manual approval, and add
integrations/agentos_hook.py so KAVACH runs as AgentOS PreToolUse hooks.

Co-Authored-By: Claude Opus 5.5 <noreply@anthropic.com>
Claude-Session: https://claude.ai/code/session_01XQHoGqDGEEKBzRgKYdpYVZ
</commit_message>
<xml_diff>
--- a/deliverables/KAVACH_Solution_Deck.pptx
+++ b/deliverables/KAVACH_Solution_Deck.pptx
@@ -22,6 +22,7 @@
     <p:sldId id="272" r:id="rId18"/>
     <p:sldId id="273" r:id="rId19"/>
     <p:sldId id="274" r:id="rId20"/>
+    <p:sldId id="275" r:id="rId21"/>
   </p:sldIdLst>
   <p:sldSz cx="12192000" cy="6858000"/>
   <p:notesSz cx="6858000" cy="12192000"/>
@@ -3614,7 +3615,7 @@
                             <a:srgbClr val="1F2937"/>
                           </a:solidFill>
                         </a:rPr>
-                        <a:t>Infosys Agentic AI Foundry</a:t>
+                        <a:t>Infosys Foundry + Topaz AgentOS</a:t>
                       </a:r>
                     </a:p>
                   </a:txBody>
@@ -3635,7 +3636,7 @@
                             <a:srgbClr val="1F2937"/>
                           </a:solidFill>
                         </a:rPr>
-                        <a:t>Tool Interrupt, validators, plan verifier, RBAC</a:t>
+                        <a:t>Tool Interrupt; regex pre-tool gate + hooks → approvals queue; moderation of user text</a:t>
                       </a:r>
                     </a:p>
                   </a:txBody>
@@ -3656,7 +3657,7 @@
                             <a:srgbClr val="1F2937"/>
                           </a:solidFill>
                         </a:rPr>
-                        <a:t>Manual step-by-step approval; no automated risk triage</a:t>
+                        <a:t>Run on our suite: defaults pass 95% of unsafe actions; hardened stops them by escalating 86.5% (Appendix F)</a:t>
                       </a:r>
                     </a:p>
                   </a:txBody>
@@ -4455,7 +4456,7 @@
                 </a:solidFill>
                 <a:latin typeface="Aptos Display"/>
               </a:rPr>
-              <a:t>Appendix F · References</a:t>
+              <a:t>Appendix F · Infosys’s own guardrails, run on our suite</a:t>
             </a:r>
           </a:p>
         </p:txBody>
@@ -4468,8 +4469,8 @@
         </p:nvSpPr>
         <p:spPr>
           <a:xfrm>
-            <a:off x="475488" y="900000"/>
-            <a:ext cx="11240000" cy="5000000"/>
+            <a:off x="475488" y="680000"/>
+            <a:ext cx="9300000" cy="260000"/>
           </a:xfrm>
           <a:prstGeom prst="rect">
             <a:avLst/>
@@ -4485,9 +4486,967 @@
             <a:r>
               <a:rPr sz="1050" b="0" i="0">
                 <a:solidFill>
+                  <a:srgbClr val="5B6573"/>
+                </a:solidFill>
+              </a:rPr>
+              <a:t>Their code, loaded from the repo (commit 49fe687), on the same 222 held-out test scenarios</a:t>
+            </a:r>
+          </a:p>
+        </p:txBody>
+      </p:sp>
+      <p:graphicFrame>
+        <p:nvGraphicFramePr>
+          <p:cNvPr id="4" name="Table 3"/>
+          <p:cNvGraphicFramePr>
+            <a:graphicFrameLocks noGrp="1"/>
+          </p:cNvGraphicFramePr>
+          <p:nvPr/>
+        </p:nvGraphicFramePr>
+        <p:xfrm>
+          <a:off x="475488" y="1050000"/>
+          <a:ext cx="11240000" cy="2310000"/>
+        </p:xfrm>
+        <a:graphic>
+          <a:graphicData uri="http://schemas.openxmlformats.org/drawingml/2006/table">
+            <a:tbl>
+              <a:tblPr firstRow="1" bandRow="1">
+                <a:tableStyleId>{5C22544A-7EE6-4342-B048-85BDC9FD1C3A}</a:tableStyleId>
+              </a:tblPr>
+              <a:tblGrid>
+                <a:gridCol w="4040000"/>
+                <a:gridCol w="1800000"/>
+                <a:gridCol w="1800000"/>
+                <a:gridCol w="1800000"/>
+                <a:gridCol w="1800000"/>
+              </a:tblGrid>
+              <a:tr h="330000">
+                <a:tc>
+                  <a:txBody>
+                    <a:bodyPr/>
+                    <a:lstStyle/>
+                    <a:p>
+                      <a:r>
+                        <a:rPr sz="950" b="1" i="0">
+                          <a:solidFill>
+                            <a:srgbClr val="FFFFFF"/>
+                          </a:solidFill>
+                        </a:rPr>
+                        <a:t>System</a:t>
+                      </a:r>
+                    </a:p>
+                  </a:txBody>
+                  <a:tcPr marL="60000" marR="60000" marT="25000" marB="25000">
+                    <a:solidFill>
+                      <a:srgbClr val="007CC3"/>
+                    </a:solidFill>
+                  </a:tcPr>
+                </a:tc>
+                <a:tc>
+                  <a:txBody>
+                    <a:bodyPr/>
+                    <a:lstStyle/>
+                    <a:p>
+                      <a:r>
+                        <a:rPr sz="950" b="1" i="0">
+                          <a:solidFill>
+                            <a:srgbClr val="FFFFFF"/>
+                          </a:solidFill>
+                        </a:rPr>
+                        <a:t>Unsafe auto-allowed</a:t>
+                      </a:r>
+                    </a:p>
+                  </a:txBody>
+                  <a:tcPr marL="60000" marR="60000" marT="25000" marB="25000">
+                    <a:solidFill>
+                      <a:srgbClr val="007CC3"/>
+                    </a:solidFill>
+                  </a:tcPr>
+                </a:tc>
+                <a:tc>
+                  <a:txBody>
+                    <a:bodyPr/>
+                    <a:lstStyle/>
+                    <a:p>
+                      <a:r>
+                        <a:rPr sz="950" b="1" i="0">
+                          <a:solidFill>
+                            <a:srgbClr val="FFFFFF"/>
+                          </a:solidFill>
+                        </a:rPr>
+                        <a:t>Injection success</a:t>
+                      </a:r>
+                    </a:p>
+                  </a:txBody>
+                  <a:tcPr marL="60000" marR="60000" marT="25000" marB="25000">
+                    <a:solidFill>
+                      <a:srgbClr val="007CC3"/>
+                    </a:solidFill>
+                  </a:tcPr>
+                </a:tc>
+                <a:tc>
+                  <a:txBody>
+                    <a:bodyPr/>
+                    <a:lstStyle/>
+                    <a:p>
+                      <a:r>
+                        <a:rPr sz="950" b="1" i="0">
+                          <a:solidFill>
+                            <a:srgbClr val="FFFFFF"/>
+                          </a:solidFill>
+                        </a:rPr>
+                        <a:t>Safe work automated</a:t>
+                      </a:r>
+                    </a:p>
+                  </a:txBody>
+                  <a:tcPr marL="60000" marR="60000" marT="25000" marB="25000">
+                    <a:solidFill>
+                      <a:srgbClr val="007CC3"/>
+                    </a:solidFill>
+                  </a:tcPr>
+                </a:tc>
+                <a:tc>
+                  <a:txBody>
+                    <a:bodyPr/>
+                    <a:lstStyle/>
+                    <a:p>
+                      <a:r>
+                        <a:rPr sz="950" b="1" i="0">
+                          <a:solidFill>
+                            <a:srgbClr val="FFFFFF"/>
+                          </a:solidFill>
+                        </a:rPr>
+                        <a:t>Sent to a human</a:t>
+                      </a:r>
+                    </a:p>
+                  </a:txBody>
+                  <a:tcPr marL="60000" marR="60000" marT="25000" marB="25000">
+                    <a:solidFill>
+                      <a:srgbClr val="007CC3"/>
+                    </a:solidFill>
+                  </a:tcPr>
+                </a:tc>
+              </a:tr>
+              <a:tr h="330000">
+                <a:tc>
+                  <a:txBody>
+                    <a:bodyPr/>
+                    <a:lstStyle/>
+                    <a:p>
+                      <a:r>
+                        <a:rPr sz="950" b="0" i="0">
+                          <a:solidFill>
+                            <a:srgbClr val="1F2937"/>
+                          </a:solidFill>
+                        </a:rPr>
+                        <a:t>PromptGuard (scans user query only)</a:t>
+                      </a:r>
+                    </a:p>
+                  </a:txBody>
+                  <a:tcPr marL="60000" marR="60000" marT="25000" marB="25000">
+                    <a:solidFill>
+                      <a:srgbClr val="F5F7FA"/>
+                    </a:solidFill>
+                  </a:tcPr>
+                </a:tc>
+                <a:tc>
+                  <a:txBody>
+                    <a:bodyPr/>
+                    <a:lstStyle/>
+                    <a:p>
+                      <a:r>
+                        <a:rPr sz="950" b="0" i="0">
+                          <a:solidFill>
+                            <a:srgbClr val="1F2937"/>
+                          </a:solidFill>
+                        </a:rPr>
+                        <a:t>100.0%</a:t>
+                      </a:r>
+                    </a:p>
+                  </a:txBody>
+                  <a:tcPr marL="60000" marR="60000" marT="25000" marB="25000">
+                    <a:solidFill>
+                      <a:srgbClr val="F5F7FA"/>
+                    </a:solidFill>
+                  </a:tcPr>
+                </a:tc>
+                <a:tc>
+                  <a:txBody>
+                    <a:bodyPr/>
+                    <a:lstStyle/>
+                    <a:p>
+                      <a:r>
+                        <a:rPr sz="950" b="0" i="0">
+                          <a:solidFill>
+                            <a:srgbClr val="1F2937"/>
+                          </a:solidFill>
+                        </a:rPr>
+                        <a:t>100%</a:t>
+                      </a:r>
+                    </a:p>
+                  </a:txBody>
+                  <a:tcPr marL="60000" marR="60000" marT="25000" marB="25000">
+                    <a:solidFill>
+                      <a:srgbClr val="F5F7FA"/>
+                    </a:solidFill>
+                  </a:tcPr>
+                </a:tc>
+                <a:tc>
+                  <a:txBody>
+                    <a:bodyPr/>
+                    <a:lstStyle/>
+                    <a:p>
+                      <a:r>
+                        <a:rPr sz="950" b="0" i="0">
+                          <a:solidFill>
+                            <a:srgbClr val="1F2937"/>
+                          </a:solidFill>
+                        </a:rPr>
+                        <a:t>100.0%</a:t>
+                      </a:r>
+                    </a:p>
+                  </a:txBody>
+                  <a:tcPr marL="60000" marR="60000" marT="25000" marB="25000">
+                    <a:solidFill>
+                      <a:srgbClr val="F5F7FA"/>
+                    </a:solidFill>
+                  </a:tcPr>
+                </a:tc>
+                <a:tc>
+                  <a:txBody>
+                    <a:bodyPr/>
+                    <a:lstStyle/>
+                    <a:p>
+                      <a:r>
+                        <a:rPr sz="950" b="0" i="0">
+                          <a:solidFill>
+                            <a:srgbClr val="1F2937"/>
+                          </a:solidFill>
+                        </a:rPr>
+                        <a:t>0.0%</a:t>
+                      </a:r>
+                    </a:p>
+                  </a:txBody>
+                  <a:tcPr marL="60000" marR="60000" marT="25000" marB="25000">
+                    <a:solidFill>
+                      <a:srgbClr val="F5F7FA"/>
+                    </a:solidFill>
+                  </a:tcPr>
+                </a:tc>
+              </a:tr>
+              <a:tr h="330000">
+                <a:tc>
+                  <a:txBody>
+                    <a:bodyPr/>
+                    <a:lstStyle/>
+                    <a:p>
+                      <a:r>
+                        <a:rPr sz="950" b="0" i="0">
+                          <a:solidFill>
+                            <a:srgbClr val="1F2937"/>
+                          </a:solidFill>
+                        </a:rPr>
+                        <a:t>RAI moderation (perfect-classifier bound)</a:t>
+                      </a:r>
+                    </a:p>
+                  </a:txBody>
+                  <a:tcPr marL="60000" marR="60000" marT="25000" marB="25000">
+                    <a:solidFill>
+                      <a:srgbClr val="FFFFFF"/>
+                    </a:solidFill>
+                  </a:tcPr>
+                </a:tc>
+                <a:tc>
+                  <a:txBody>
+                    <a:bodyPr/>
+                    <a:lstStyle/>
+                    <a:p>
+                      <a:r>
+                        <a:rPr sz="950" b="0" i="0">
+                          <a:solidFill>
+                            <a:srgbClr val="1F2937"/>
+                          </a:solidFill>
+                        </a:rPr>
+                        <a:t>100.0%</a:t>
+                      </a:r>
+                    </a:p>
+                  </a:txBody>
+                  <a:tcPr marL="60000" marR="60000" marT="25000" marB="25000">
+                    <a:solidFill>
+                      <a:srgbClr val="FFFFFF"/>
+                    </a:solidFill>
+                  </a:tcPr>
+                </a:tc>
+                <a:tc>
+                  <a:txBody>
+                    <a:bodyPr/>
+                    <a:lstStyle/>
+                    <a:p>
+                      <a:r>
+                        <a:rPr sz="950" b="0" i="0">
+                          <a:solidFill>
+                            <a:srgbClr val="1F2937"/>
+                          </a:solidFill>
+                        </a:rPr>
+                        <a:t>100%</a:t>
+                      </a:r>
+                    </a:p>
+                  </a:txBody>
+                  <a:tcPr marL="60000" marR="60000" marT="25000" marB="25000">
+                    <a:solidFill>
+                      <a:srgbClr val="FFFFFF"/>
+                    </a:solidFill>
+                  </a:tcPr>
+                </a:tc>
+                <a:tc>
+                  <a:txBody>
+                    <a:bodyPr/>
+                    <a:lstStyle/>
+                    <a:p>
+                      <a:r>
+                        <a:rPr sz="950" b="0" i="0">
+                          <a:solidFill>
+                            <a:srgbClr val="1F2937"/>
+                          </a:solidFill>
+                        </a:rPr>
+                        <a:t>100.0%</a:t>
+                      </a:r>
+                    </a:p>
+                  </a:txBody>
+                  <a:tcPr marL="60000" marR="60000" marT="25000" marB="25000">
+                    <a:solidFill>
+                      <a:srgbClr val="FFFFFF"/>
+                    </a:solidFill>
+                  </a:tcPr>
+                </a:tc>
+                <a:tc>
+                  <a:txBody>
+                    <a:bodyPr/>
+                    <a:lstStyle/>
+                    <a:p>
+                      <a:r>
+                        <a:rPr sz="950" b="0" i="0">
+                          <a:solidFill>
+                            <a:srgbClr val="1F2937"/>
+                          </a:solidFill>
+                        </a:rPr>
+                        <a:t>0.0%</a:t>
+                      </a:r>
+                    </a:p>
+                  </a:txBody>
+                  <a:tcPr marL="60000" marR="60000" marT="25000" marB="25000">
+                    <a:solidFill>
+                      <a:srgbClr val="FFFFFF"/>
+                    </a:solidFill>
+                  </a:tcPr>
+                </a:tc>
+              </a:tr>
+              <a:tr h="330000">
+                <a:tc>
+                  <a:txBody>
+                    <a:bodyPr/>
+                    <a:lstStyle/>
+                    <a:p>
+                      <a:r>
+                        <a:rPr sz="950" b="0" i="0">
+                          <a:solidFill>
+                            <a:srgbClr val="1F2937"/>
+                          </a:solidFill>
+                        </a:rPr>
+                        <a:t>AgentOS gate, default config</a:t>
+                      </a:r>
+                    </a:p>
+                  </a:txBody>
+                  <a:tcPr marL="60000" marR="60000" marT="25000" marB="25000">
+                    <a:solidFill>
+                      <a:srgbClr val="F5F7FA"/>
+                    </a:solidFill>
+                  </a:tcPr>
+                </a:tc>
+                <a:tc>
+                  <a:txBody>
+                    <a:bodyPr/>
+                    <a:lstStyle/>
+                    <a:p>
+                      <a:r>
+                        <a:rPr sz="950" b="0" i="0">
+                          <a:solidFill>
+                            <a:srgbClr val="1F2937"/>
+                          </a:solidFill>
+                        </a:rPr>
+                        <a:t>95.0%</a:t>
+                      </a:r>
+                    </a:p>
+                  </a:txBody>
+                  <a:tcPr marL="60000" marR="60000" marT="25000" marB="25000">
+                    <a:solidFill>
+                      <a:srgbClr val="F5F7FA"/>
+                    </a:solidFill>
+                  </a:tcPr>
+                </a:tc>
+                <a:tc>
+                  <a:txBody>
+                    <a:bodyPr/>
+                    <a:lstStyle/>
+                    <a:p>
+                      <a:r>
+                        <a:rPr sz="950" b="0" i="0">
+                          <a:solidFill>
+                            <a:srgbClr val="1F2937"/>
+                          </a:solidFill>
+                        </a:rPr>
+                        <a:t>100%</a:t>
+                      </a:r>
+                    </a:p>
+                  </a:txBody>
+                  <a:tcPr marL="60000" marR="60000" marT="25000" marB="25000">
+                    <a:solidFill>
+                      <a:srgbClr val="F5F7FA"/>
+                    </a:solidFill>
+                  </a:tcPr>
+                </a:tc>
+                <a:tc>
+                  <a:txBody>
+                    <a:bodyPr/>
+                    <a:lstStyle/>
+                    <a:p>
+                      <a:r>
+                        <a:rPr sz="950" b="0" i="0">
+                          <a:solidFill>
+                            <a:srgbClr val="1F2937"/>
+                          </a:solidFill>
+                        </a:rPr>
+                        <a:t>100.0%</a:t>
+                      </a:r>
+                    </a:p>
+                  </a:txBody>
+                  <a:tcPr marL="60000" marR="60000" marT="25000" marB="25000">
+                    <a:solidFill>
+                      <a:srgbClr val="F5F7FA"/>
+                    </a:solidFill>
+                  </a:tcPr>
+                </a:tc>
+                <a:tc>
+                  <a:txBody>
+                    <a:bodyPr/>
+                    <a:lstStyle/>
+                    <a:p>
+                      <a:r>
+                        <a:rPr sz="950" b="0" i="0">
+                          <a:solidFill>
+                            <a:srgbClr val="1F2937"/>
+                          </a:solidFill>
+                        </a:rPr>
+                        <a:t>0.0%</a:t>
+                      </a:r>
+                    </a:p>
+                  </a:txBody>
+                  <a:tcPr marL="60000" marR="60000" marT="25000" marB="25000">
+                    <a:solidFill>
+                      <a:srgbClr val="F5F7FA"/>
+                    </a:solidFill>
+                  </a:tcPr>
+                </a:tc>
+              </a:tr>
+              <a:tr h="330000">
+                <a:tc>
+                  <a:txBody>
+                    <a:bodyPr/>
+                    <a:lstStyle/>
+                    <a:p>
+                      <a:r>
+                        <a:rPr sz="950" b="0" i="0">
+                          <a:solidFill>
+                            <a:srgbClr val="1F2937"/>
+                          </a:solidFill>
+                        </a:rPr>
+                        <a:t>AgentOS gate, hardened (SQL + sends + payments)</a:t>
+                      </a:r>
+                    </a:p>
+                  </a:txBody>
+                  <a:tcPr marL="60000" marR="60000" marT="25000" marB="25000">
+                    <a:solidFill>
+                      <a:srgbClr val="FFFFFF"/>
+                    </a:solidFill>
+                  </a:tcPr>
+                </a:tc>
+                <a:tc>
+                  <a:txBody>
+                    <a:bodyPr/>
+                    <a:lstStyle/>
+                    <a:p>
+                      <a:r>
+                        <a:rPr sz="950" b="0" i="0">
+                          <a:solidFill>
+                            <a:srgbClr val="1F2937"/>
+                          </a:solidFill>
+                        </a:rPr>
+                        <a:t>5.0%</a:t>
+                      </a:r>
+                    </a:p>
+                  </a:txBody>
+                  <a:tcPr marL="60000" marR="60000" marT="25000" marB="25000">
+                    <a:solidFill>
+                      <a:srgbClr val="FFFFFF"/>
+                    </a:solidFill>
+                  </a:tcPr>
+                </a:tc>
+                <a:tc>
+                  <a:txBody>
+                    <a:bodyPr/>
+                    <a:lstStyle/>
+                    <a:p>
+                      <a:r>
+                        <a:rPr sz="950" b="0" i="0">
+                          <a:solidFill>
+                            <a:srgbClr val="1F2937"/>
+                          </a:solidFill>
+                        </a:rPr>
+                        <a:t>0%</a:t>
+                      </a:r>
+                    </a:p>
+                  </a:txBody>
+                  <a:tcPr marL="60000" marR="60000" marT="25000" marB="25000">
+                    <a:solidFill>
+                      <a:srgbClr val="FFFFFF"/>
+                    </a:solidFill>
+                  </a:tcPr>
+                </a:tc>
+                <a:tc>
+                  <a:txBody>
+                    <a:bodyPr/>
+                    <a:lstStyle/>
+                    <a:p>
+                      <a:r>
+                        <a:rPr sz="950" b="0" i="0">
+                          <a:solidFill>
+                            <a:srgbClr val="1F2937"/>
+                          </a:solidFill>
+                        </a:rPr>
+                        <a:t>17.6%</a:t>
+                      </a:r>
+                    </a:p>
+                  </a:txBody>
+                  <a:tcPr marL="60000" marR="60000" marT="25000" marB="25000">
+                    <a:solidFill>
+                      <a:srgbClr val="FFFFFF"/>
+                    </a:solidFill>
+                  </a:tcPr>
+                </a:tc>
+                <a:tc>
+                  <a:txBody>
+                    <a:bodyPr/>
+                    <a:lstStyle/>
+                    <a:p>
+                      <a:r>
+                        <a:rPr sz="950" b="0" i="0">
+                          <a:solidFill>
+                            <a:srgbClr val="1F2937"/>
+                          </a:solidFill>
+                        </a:rPr>
+                        <a:t>86.5%</a:t>
+                      </a:r>
+                    </a:p>
+                  </a:txBody>
+                  <a:tcPr marL="60000" marR="60000" marT="25000" marB="25000">
+                    <a:solidFill>
+                      <a:srgbClr val="FFFFFF"/>
+                    </a:solidFill>
+                  </a:tcPr>
+                </a:tc>
+              </a:tr>
+              <a:tr h="330000">
+                <a:tc>
+                  <a:txBody>
+                    <a:bodyPr/>
+                    <a:lstStyle/>
+                    <a:p>
+                      <a:r>
+                        <a:rPr sz="950" b="0" i="0">
+                          <a:solidFill>
+                            <a:srgbClr val="1F2937"/>
+                          </a:solidFill>
+                        </a:rPr>
+                        <a:t>Tool Interrupt on every state change</a:t>
+                      </a:r>
+                    </a:p>
+                  </a:txBody>
+                  <a:tcPr marL="60000" marR="60000" marT="25000" marB="25000">
+                    <a:solidFill>
+                      <a:srgbClr val="F5F7FA"/>
+                    </a:solidFill>
+                  </a:tcPr>
+                </a:tc>
+                <a:tc>
+                  <a:txBody>
+                    <a:bodyPr/>
+                    <a:lstStyle/>
+                    <a:p>
+                      <a:r>
+                        <a:rPr sz="950" b="0" i="0">
+                          <a:solidFill>
+                            <a:srgbClr val="1F2937"/>
+                          </a:solidFill>
+                        </a:rPr>
+                        <a:t>5.0%</a:t>
+                      </a:r>
+                    </a:p>
+                  </a:txBody>
+                  <a:tcPr marL="60000" marR="60000" marT="25000" marB="25000">
+                    <a:solidFill>
+                      <a:srgbClr val="F5F7FA"/>
+                    </a:solidFill>
+                  </a:tcPr>
+                </a:tc>
+                <a:tc>
+                  <a:txBody>
+                    <a:bodyPr/>
+                    <a:lstStyle/>
+                    <a:p>
+                      <a:r>
+                        <a:rPr sz="950" b="0" i="0">
+                          <a:solidFill>
+                            <a:srgbClr val="1F2937"/>
+                          </a:solidFill>
+                        </a:rPr>
+                        <a:t>0%</a:t>
+                      </a:r>
+                    </a:p>
+                  </a:txBody>
+                  <a:tcPr marL="60000" marR="60000" marT="25000" marB="25000">
+                    <a:solidFill>
+                      <a:srgbClr val="F5F7FA"/>
+                    </a:solidFill>
+                  </a:tcPr>
+                </a:tc>
+                <a:tc>
+                  <a:txBody>
+                    <a:bodyPr/>
+                    <a:lstStyle/>
+                    <a:p>
+                      <a:r>
+                        <a:rPr sz="950" b="0" i="0">
+                          <a:solidFill>
+                            <a:srgbClr val="1F2937"/>
+                          </a:solidFill>
+                        </a:rPr>
+                        <a:t>11.8%</a:t>
+                      </a:r>
+                    </a:p>
+                  </a:txBody>
+                  <a:tcPr marL="60000" marR="60000" marT="25000" marB="25000">
+                    <a:solidFill>
+                      <a:srgbClr val="F5F7FA"/>
+                    </a:solidFill>
+                  </a:tcPr>
+                </a:tc>
+                <a:tc>
+                  <a:txBody>
+                    <a:bodyPr/>
+                    <a:lstStyle/>
+                    <a:p>
+                      <a:r>
+                        <a:rPr sz="950" b="0" i="0">
+                          <a:solidFill>
+                            <a:srgbClr val="1F2937"/>
+                          </a:solidFill>
+                        </a:rPr>
+                        <a:t>91.9%</a:t>
+                      </a:r>
+                    </a:p>
+                  </a:txBody>
+                  <a:tcPr marL="60000" marR="60000" marT="25000" marB="25000">
+                    <a:solidFill>
+                      <a:srgbClr val="F5F7FA"/>
+                    </a:solidFill>
+                  </a:tcPr>
+                </a:tc>
+              </a:tr>
+              <a:tr h="330000">
+                <a:tc>
+                  <a:txBody>
+                    <a:bodyPr/>
+                    <a:lstStyle/>
+                    <a:p>
+                      <a:r>
+                        <a:rPr sz="950" b="0" i="0">
+                          <a:solidFill>
+                            <a:srgbClr val="1F2937"/>
+                          </a:solidFill>
+                        </a:rPr>
+                        <a:t>KAVACH</a:t>
+                      </a:r>
+                    </a:p>
+                  </a:txBody>
+                  <a:tcPr marL="60000" marR="60000" marT="25000" marB="25000">
+                    <a:solidFill>
+                      <a:srgbClr val="FFFFFF"/>
+                    </a:solidFill>
+                  </a:tcPr>
+                </a:tc>
+                <a:tc>
+                  <a:txBody>
+                    <a:bodyPr/>
+                    <a:lstStyle/>
+                    <a:p>
+                      <a:r>
+                        <a:rPr sz="950" b="0" i="0">
+                          <a:solidFill>
+                            <a:srgbClr val="1F2937"/>
+                          </a:solidFill>
+                        </a:rPr>
+                        <a:t>0.8%</a:t>
+                      </a:r>
+                    </a:p>
+                  </a:txBody>
+                  <a:tcPr marL="60000" marR="60000" marT="25000" marB="25000">
+                    <a:solidFill>
+                      <a:srgbClr val="FFFFFF"/>
+                    </a:solidFill>
+                  </a:tcPr>
+                </a:tc>
+                <a:tc>
+                  <a:txBody>
+                    <a:bodyPr/>
+                    <a:lstStyle/>
+                    <a:p>
+                      <a:r>
+                        <a:rPr sz="950" b="0" i="0">
+                          <a:solidFill>
+                            <a:srgbClr val="1F2937"/>
+                          </a:solidFill>
+                        </a:rPr>
+                        <a:t>0%</a:t>
+                      </a:r>
+                    </a:p>
+                  </a:txBody>
+                  <a:tcPr marL="60000" marR="60000" marT="25000" marB="25000">
+                    <a:solidFill>
+                      <a:srgbClr val="FFFFFF"/>
+                    </a:solidFill>
+                  </a:tcPr>
+                </a:tc>
+                <a:tc>
+                  <a:txBody>
+                    <a:bodyPr/>
+                    <a:lstStyle/>
+                    <a:p>
+                      <a:r>
+                        <a:rPr sz="950" b="0" i="0">
+                          <a:solidFill>
+                            <a:srgbClr val="1F2937"/>
+                          </a:solidFill>
+                        </a:rPr>
+                        <a:t>70.6%</a:t>
+                      </a:r>
+                    </a:p>
+                  </a:txBody>
+                  <a:tcPr marL="60000" marR="60000" marT="25000" marB="25000">
+                    <a:solidFill>
+                      <a:srgbClr val="FFFFFF"/>
+                    </a:solidFill>
+                  </a:tcPr>
+                </a:tc>
+                <a:tc>
+                  <a:txBody>
+                    <a:bodyPr/>
+                    <a:lstStyle/>
+                    <a:p>
+                      <a:r>
+                        <a:rPr sz="950" b="0" i="0">
+                          <a:solidFill>
+                            <a:srgbClr val="1F2937"/>
+                          </a:solidFill>
+                        </a:rPr>
+                        <a:t>34.7%</a:t>
+                      </a:r>
+                    </a:p>
+                  </a:txBody>
+                  <a:tcPr marL="60000" marR="60000" marT="25000" marB="25000">
+                    <a:solidFill>
+                      <a:srgbClr val="FFFFFF"/>
+                    </a:solidFill>
+                  </a:tcPr>
+                </a:tc>
+              </a:tr>
+            </a:tbl>
+          </a:graphicData>
+        </a:graphic>
+      </p:graphicFrame>
+      <p:sp>
+        <p:nvSpPr>
+          <p:cNvPr id="5" name="TextBox 4"/>
+          <p:cNvSpPr txBox="1"/>
+          <p:nvPr/>
+        </p:nvSpPr>
+        <p:spPr>
+          <a:xfrm>
+            <a:off x="475488" y="3500000"/>
+            <a:ext cx="11240000" cy="2300000"/>
+          </a:xfrm>
+          <a:prstGeom prst="rect">
+            <a:avLst/>
+          </a:prstGeom>
+          <a:noFill/>
+        </p:spPr>
+        <p:txBody>
+          <a:bodyPr wrap="square">
+            <a:spAutoFit/>
+          </a:bodyPr>
+          <a:lstStyle/>
+          <a:p>
+            <a:r>
+              <a:rPr sz="1000" b="1" i="0">
+                <a:solidFill>
                   <a:srgbClr val="1F2937"/>
                 </a:solidFill>
               </a:rPr>
+              <a:t>Authorized:</a:t>
+            </a:r>
+            <a:r>
+              <a:rPr sz="1000" b="0" i="0">
+                <a:solidFill>
+                  <a:srgbClr val="1F2937"/>
+                </a:solidFill>
+              </a:rPr>
+              <a:t> PromptGuard and the RAI proxy scan only the user’s text; tool outputs (where indirect injections live) are never sent, so even a perfect classifier misses them.</a:t>
+            </a:r>
+          </a:p>
+          <a:p>
+            <a:r>
+              <a:rPr sz="1000" b="1" i="0">
+                <a:solidFill>
+                  <a:srgbClr val="1F2937"/>
+                </a:solidFill>
+              </a:rPr>
+              <a:t>Safe:</a:t>
+            </a:r>
+            <a:r>
+              <a:rPr sz="1000" b="0" i="0">
+                <a:solidFill>
+                  <a:srgbClr val="1F2937"/>
+                </a:solidFill>
+              </a:rPr>
+              <a:t> the AgentOS gate matches command text (regex), not effects; the SQL gate is empty by default. Business thresholds in approval_rules are enforced by the agent’s own LLM.</a:t>
+            </a:r>
+          </a:p>
+          <a:p>
+            <a:r>
+              <a:rPr sz="1000" b="1" i="0">
+                <a:solidFill>
+                  <a:srgbClr val="1F2937"/>
+                </a:solidFill>
+              </a:rPr>
+              <a:t>Explainable / reversible:</a:t>
+            </a:r>
+            <a:r>
+              <a:rPr sz="1000" b="0" i="0">
+                <a:solidFill>
+                  <a:srgbClr val="1F2937"/>
+                </a:solidFill>
+              </a:rPr>
+              <a:t> approval cards show tool + 200-char preview; no provenance, blast radius, undo or tamper-evident audit.</a:t>
+            </a:r>
+          </a:p>
+          <a:p>
+            <a:r>
+              <a:rPr sz="1000" b="1" i="0">
+                <a:solidFill>
+                  <a:srgbClr val="1F2937"/>
+                </a:solidFill>
+              </a:rPr>
+              <a:t>Fit:</a:t>
+            </a:r>
+            <a:r>
+              <a:rPr sz="1000" b="0" i="0">
+                <a:solidFill>
+                  <a:srgbClr val="1F2937"/>
+                </a:solidFill>
+              </a:rPr>
+              <a:t> KAVACH runs as an AgentOS PreToolUse hook (integrations/agentos_hook.py). AgentOS keeps routing, sandbox and the approvals queue; KAVACH decides what goes into it.</a:t>
+            </a:r>
+          </a:p>
+        </p:txBody>
+      </p:sp>
+    </p:spTree>
+  </p:cSld>
+  <p:clrMapOvr>
+    <a:masterClrMapping/>
+  </p:clrMapOvr>
+</p:sld>
+</file>
+
+<file path=ppt/slides/slide15.xml><?xml version="1.0" encoding="utf-8"?>
+<p:sld xmlns:a="http://schemas.openxmlformats.org/drawingml/2006/main" xmlns:p="http://schemas.openxmlformats.org/presentationml/2006/main" xmlns:r="http://schemas.openxmlformats.org/officeDocument/2006/relationships">
+  <p:cSld>
+    <p:spTree>
+      <p:nvGrpSpPr>
+        <p:cNvPr id="1" name=""/>
+        <p:cNvGrpSpPr/>
+        <p:nvPr/>
+      </p:nvGrpSpPr>
+      <p:grpSpPr/>
+      <p:sp>
+        <p:nvSpPr>
+          <p:cNvPr id="2" name="TextBox 1"/>
+          <p:cNvSpPr txBox="1"/>
+          <p:nvPr/>
+        </p:nvSpPr>
+        <p:spPr>
+          <a:xfrm>
+            <a:off x="475488" y="256032"/>
+            <a:ext cx="8869680" cy="420000"/>
+          </a:xfrm>
+          <a:prstGeom prst="rect">
+            <a:avLst/>
+          </a:prstGeom>
+          <a:noFill/>
+        </p:spPr>
+        <p:txBody>
+          <a:bodyPr wrap="square">
+            <a:spAutoFit/>
+          </a:bodyPr>
+          <a:lstStyle/>
+          <a:p>
+            <a:r>
+              <a:rPr sz="2400" b="0" i="0">
+                <a:solidFill>
+                  <a:srgbClr val="111827"/>
+                </a:solidFill>
+                <a:latin typeface="Aptos Display"/>
+              </a:rPr>
+              <a:t>Appendix G · References</a:t>
+            </a:r>
+          </a:p>
+        </p:txBody>
+      </p:sp>
+      <p:sp>
+        <p:nvSpPr>
+          <p:cNvPr id="3" name="TextBox 2"/>
+          <p:cNvSpPr txBox="1"/>
+          <p:nvPr/>
+        </p:nvSpPr>
+        <p:spPr>
+          <a:xfrm>
+            <a:off x="475488" y="900000"/>
+            <a:ext cx="11240000" cy="5000000"/>
+          </a:xfrm>
+          <a:prstGeom prst="rect">
+            <a:avLst/>
+          </a:prstGeom>
+          <a:noFill/>
+        </p:spPr>
+        <p:txBody>
+          <a:bodyPr wrap="square">
+            <a:spAutoFit/>
+          </a:bodyPr>
+          <a:lstStyle/>
+          <a:p>
+            <a:r>
+              <a:rPr sz="1050" b="0" i="0">
+                <a:solidFill>
+                  <a:srgbClr val="1F2937"/>
+                </a:solidFill>
+              </a:rPr>
               <a:t>AgentDojo, NeurIPS 2024 D&amp;B (arXiv 2406.13352) · CaMeL, arXiv 2503.18813 · LlamaFirewall, arXiv 2505.03574 · Progent, arXiv 2504.11703</a:t>
             </a:r>
           </a:p>
@@ -4548,7 +5507,7 @@
                   <a:srgbClr val="1F2937"/>
                 </a:solidFill>
               </a:rPr>
-              <a:t>Infosys Agentic AI Foundry (v1.6–1.9 release notes) · Infosys Responsible AI Toolkit · Qualcomm python-imagine-sdk 0.5.0</a:t>
+              <a:t>Infosys Agentic AI Foundry (commit 49fe687: v1.9 + Topaz AgentOS 1.0.0 source) · Infosys Responsible AI Toolkit 2.2.1 · Qualcomm python-imagine-sdk 0.5.0</a:t>
             </a:r>
           </a:p>
           <a:p>
@@ -11040,7 +11999,7 @@
                   <a:srgbClr val="1F2937"/>
                 </a:solidFill>
               </a:rPr>
-              <a:t>Infosys Foundry plug-in: KAVACH as the MCP endpoint; Tool Interrupt fires only on ESCALATE</a:t>
+              <a:t>Infosys AgentOS hook (built): DENY blocks, ESCALATE → #approvals queue; next: live tenant run</a:t>
             </a:r>
             <a:endParaRPr lang="en-US" sz="1150" dirty="0"/>
           </a:p>
@@ -11164,7 +12123,7 @@
                   <a:srgbClr val="1F2937"/>
                 </a:solidFill>
               </a:rPr>
-              <a:t>Port AgentDojo + AmPermBench; RAI Toolkit Privacy API as the PII detector</a:t>
+              <a:t>Port AgentDojo + AmPermBench; RAI injection classifier applied to tool outputs</a:t>
             </a:r>
             <a:endParaRPr lang="en-US" sz="1150" dirty="0"/>
           </a:p>
@@ -12389,7 +13348,7 @@
                     <a:srgbClr val="1F2937"/>
                   </a:solidFill>
                 </a:rPr>
-                <a:t> gateway, 12 rules, provenance, SQL/file sandbox, calibrated risk + HITL, receipts, undo, MCP front door, Qualcomm client, benchmark.</a:t>
+                <a:t> gateway, 12 rules, provenance, SQL/file sandbox, calibrated risk + HITL, receipts, undo, MCP front door, Infosys AgentOS hook adapter, Qualcomm client, benchmark.</a:t>
               </a:r>
               <a:endParaRPr lang="en-US" sz="1100" dirty="0"/>
             </a:p>
@@ -12412,7 +13371,7 @@
                     <a:srgbClr val="1F2937"/>
                   </a:solidFill>
                 </a:rPr>
-                <a:t> Foundry plug-in and published-benchmark ports. </a:t>
+                <a:t> live AgentOS tenant run and published-benchmark ports. </a:t>
               </a:r>
               <a:r>
                 <a:rPr sz="1000" b="1" i="0">

</xml_diff>